<commit_message>
Met a jour la verification apres l extension du broadcast
Vingt cas de regression au lieu de seize, empreinte du JAR courant, et
durees relevees apres la diffusion des trois referentiels : le total
passe de 122,94 s a 95,93 s sur la meme machine, soit 22 % de moins.

Les volumes et les indicateurs metier sont inchanges : 138 047 lues,
1 890 rejets de validation, 11 406 rejets de jointure, 124 751 analysees
et 49 897 506,62 EUR.
</commit_message>
<xml_diff>
--- a/soutenance/Presentation_Groupe9.pptx
+++ b/soutenance/Presentation_Groupe9.pptx
@@ -11502,7 +11502,7 @@
                 <a:ea typeface="Calibri" pitchFamily="34" charset="-122"/>
                 <a:cs typeface="Calibri" pitchFamily="34" charset="-120"/>
               </a:rPr>
-              <a:t>Seize cas isolés couvrant les frontières et les règles métier.</a:t>
+              <a:t>Vingt cas isolés couvrant les frontières et les règles métier.</a:t>
             </a:r>
             <a:endParaRPr lang="en-US" sz="1150" dirty="0"/>
           </a:p>
@@ -11614,7 +11614,7 @@
                 <a:ea typeface="Calibri" pitchFamily="34" charset="-122"/>
                 <a:cs typeface="Calibri" pitchFamily="34" charset="-120"/>
               </a:rPr>
-              <a:t>16 / 16</a:t>
+              <a:t>20 / 20</a:t>
             </a:r>
             <a:endParaRPr lang="en-US" sz="2100" dirty="0"/>
           </a:p>
@@ -11726,7 +11726,7 @@
                 <a:ea typeface="Calibri" pitchFamily="34" charset="-122"/>
                 <a:cs typeface="Calibri" pitchFamily="34" charset="-120"/>
               </a:rPr>
-              <a:t>123 s</a:t>
+              <a:t>96 s</a:t>
             </a:r>
             <a:endParaRPr lang="en-US" sz="2100" dirty="0"/>
           </a:p>

</xml_diff>